<commit_message>
Make decision tree workflow reusable
</commit_message>
<xml_diff>
--- a/decision_tree_python_slides.pptx
+++ b/decision_tree_python_slides.pptx
@@ -3262,7 +3262,8 @@
               </a:defRPr>
             </a:pPr>
             <a:r>
-              <a:t>Credit dataset  •  Step-by-step code  •  Google Colab</a:t>
+              <a:rPr/>
+              <a:t>Reusable workflow  •  Bring your own CSV  •  Google Colab</a:t>
             </a:r>
           </a:p>
         </p:txBody>
@@ -3467,7 +3468,8 @@
               </a:defRPr>
             </a:pPr>
             <a:r>
-              <a:t>One-hot encode category codes</a:t>
+              <a:rPr/>
+              <a:t>Impute missing values and encode categories</a:t>
             </a:r>
           </a:p>
         </p:txBody>
@@ -3704,23 +3706,85 @@
               </a:defRPr>
             </a:pPr>
             <a:r>
-              <a:t> 1  preprocessor = ColumnTransformer([</a:t>
-            </a:r>
-            <a:br/>
-            <a:r>
-              <a:t> 2    ("category", OneHotEncoder(</a:t>
-            </a:r>
-            <a:br/>
-            <a:r>
-              <a:t> 3        handle_unknown="ignore"), categorical_columns),</a:t>
-            </a:r>
-            <a:br/>
-            <a:r>
-              <a:t> 4    ("number", "passthrough", numeric_columns)</a:t>
-            </a:r>
-            <a:br/>
-            <a:r>
-              <a:t> 5  ])</a:t>
+              <a:rPr sz="1300">
+                <a:solidFill>
+                  <a:srgbClr val="FFFFFF"/>
+                </a:solidFill>
+                <a:latin typeface="Aptos Mono"/>
+              </a:rPr>
+              <a:t> 1  categorical_pipeline = Pipeline([</a:t>
+            </a:r>
+          </a:p>
+          <a:p>
+            <a:pPr algn="l"/>
+            <a:r>
+              <a:rPr sz="1300">
+                <a:solidFill>
+                  <a:srgbClr val="FFFFFF"/>
+                </a:solidFill>
+                <a:latin typeface="Aptos Mono"/>
+              </a:rPr>
+              <a:t> 2    ("imputer", SimpleImputer(...)),</a:t>
+            </a:r>
+          </a:p>
+          <a:p>
+            <a:pPr algn="l"/>
+            <a:r>
+              <a:rPr sz="1300">
+                <a:solidFill>
+                  <a:srgbClr val="FFFFFF"/>
+                </a:solidFill>
+                <a:latin typeface="Aptos Mono"/>
+              </a:rPr>
+              <a:t> 3    ("onehot", OneHotEncoder(...))</a:t>
+            </a:r>
+          </a:p>
+          <a:p>
+            <a:pPr algn="l"/>
+            <a:r>
+              <a:rPr sz="1300">
+                <a:solidFill>
+                  <a:srgbClr val="FFFFFF"/>
+                </a:solidFill>
+                <a:latin typeface="Aptos Mono"/>
+              </a:rPr>
+              <a:t> 4  ])</a:t>
+            </a:r>
+          </a:p>
+          <a:p>
+            <a:pPr algn="l"/>
+            <a:r>
+              <a:rPr sz="1300">
+                <a:solidFill>
+                  <a:srgbClr val="FFFFFF"/>
+                </a:solidFill>
+                <a:latin typeface="Aptos Mono"/>
+              </a:rPr>
+              <a:t> 5  numeric_pipeline = Pipeline([</a:t>
+            </a:r>
+          </a:p>
+          <a:p>
+            <a:pPr algn="l"/>
+            <a:r>
+              <a:rPr sz="1300">
+                <a:solidFill>
+                  <a:srgbClr val="FFFFFF"/>
+                </a:solidFill>
+                <a:latin typeface="Aptos Mono"/>
+              </a:rPr>
+              <a:t> 6    ("imputer", SimpleImputer(strategy="median"))</a:t>
+            </a:r>
+          </a:p>
+          <a:p>
+            <a:pPr algn="l"/>
+            <a:r>
+              <a:rPr sz="1300">
+                <a:solidFill>
+                  <a:srgbClr val="FFFFFF"/>
+                </a:solidFill>
+                <a:latin typeface="Aptos Mono"/>
+              </a:rPr>
+              <a:t> 7  ])</a:t>
             </a:r>
           </a:p>
         </p:txBody>
@@ -3756,22 +3820,50 @@
               </a:defRPr>
             </a:pPr>
             <a:r>
-              <a:t>1  Creates one coordinated transformation.</a:t>
-            </a:r>
-            <a:br/>
-            <a:br/>
-            <a:r>
-              <a:t>2–3  Makes a separate 0/1 indicator for each category. Unknown future codes will not crash prediction.</a:t>
-            </a:r>
-            <a:br/>
-            <a:br/>
-            <a:r>
-              <a:t>4  Leaves DURATION, AGE, and Amount numeric.</a:t>
-            </a:r>
-            <a:br/>
-            <a:br/>
-            <a:r>
-              <a:t>Decision trees do not need feature scaling.</a:t>
+              <a:rPr/>
+              <a:t>1–4  Fill missing categories, then make 0/1 indicator columns.</a:t>
+            </a:r>
+          </a:p>
+          <a:p>
+            <a:pPr algn="l"/>
+            <a:r>
+              <a:rPr/>
+              <a:t/>
+            </a:r>
+          </a:p>
+          <a:p>
+            <a:pPr algn="l"/>
+            <a:r>
+              <a:rPr/>
+              <a:t>5–7  Fill missing numeric values with the median.</a:t>
+            </a:r>
+          </a:p>
+          <a:p>
+            <a:pPr algn="l"/>
+            <a:r>
+              <a:rPr/>
+              <a:t/>
+            </a:r>
+          </a:p>
+          <a:p>
+            <a:pPr algn="l"/>
+            <a:r>
+              <a:rPr/>
+              <a:t>ColumnTransformer applies each pipeline to the configured columns.</a:t>
+            </a:r>
+          </a:p>
+          <a:p>
+            <a:pPr algn="l"/>
+            <a:r>
+              <a:rPr/>
+              <a:t/>
+            </a:r>
+          </a:p>
+          <a:p>
+            <a:pPr algn="l"/>
+            <a:r>
+              <a:rPr/>
+              <a:t>Decision trees do not require feature scaling.</a:t>
             </a:r>
           </a:p>
         </p:txBody>
@@ -4197,27 +4289,64 @@
               </a:defRPr>
             </a:pPr>
             <a:r>
+              <a:rPr/>
               <a:t>1–2  Separates predictors and labels together.</a:t>
             </a:r>
-            <a:br/>
-            <a:br/>
-            <a:r>
-              <a:t>3  Reserves 20% for final testing.</a:t>
-            </a:r>
-            <a:br/>
-            <a:br/>
-            <a:r>
-              <a:t>4  Makes the same split reproducible.</a:t>
-            </a:r>
-            <a:br/>
-            <a:br/>
-            <a:r>
-              <a:t>5  Preserves class proportions as closely as possible.</a:t>
-            </a:r>
-            <a:br/>
-            <a:br/>
-            <a:r>
-              <a:t>Result: 47 training rows and 12 testing rows.</a:t>
+          </a:p>
+          <a:p>
+            <a:pPr algn="l"/>
+            <a:r>
+              <a:rPr/>
+              <a:t/>
+            </a:r>
+          </a:p>
+          <a:p>
+            <a:pPr algn="l"/>
+            <a:r>
+              <a:rPr/>
+              <a:t>3  Reserves the configured test share.</a:t>
+            </a:r>
+          </a:p>
+          <a:p>
+            <a:pPr algn="l"/>
+            <a:r>
+              <a:rPr/>
+              <a:t/>
+            </a:r>
+          </a:p>
+          <a:p>
+            <a:pPr algn="l"/>
+            <a:r>
+              <a:rPr/>
+              <a:t>4  Makes the split reproducible.</a:t>
+            </a:r>
+          </a:p>
+          <a:p>
+            <a:pPr algn="l"/>
+            <a:r>
+              <a:rPr/>
+              <a:t/>
+            </a:r>
+          </a:p>
+          <a:p>
+            <a:pPr algn="l"/>
+            <a:r>
+              <a:rPr/>
+              <a:t>5  Preserves class proportions when classes have enough rows.</a:t>
+            </a:r>
+          </a:p>
+          <a:p>
+            <a:pPr algn="l"/>
+            <a:r>
+              <a:rPr/>
+              <a:t/>
+            </a:r>
+          </a:p>
+          <a:p>
+            <a:pPr algn="l"/>
+            <a:r>
+              <a:rPr/>
+              <a:t>The row counts depend on the uploaded dataset.</a:t>
             </a:r>
           </a:p>
         </p:txBody>
@@ -4587,38 +4716,108 @@
               </a:defRPr>
             </a:pPr>
             <a:r>
+              <a:rPr sz="1300">
+                <a:solidFill>
+                  <a:srgbClr val="FFFFFF"/>
+                </a:solidFill>
+                <a:latin typeface="Aptos Mono"/>
+              </a:rPr>
               <a:t> 1  model = Pipeline([</a:t>
             </a:r>
-            <a:br/>
-            <a:r>
+          </a:p>
+          <a:p>
+            <a:pPr algn="l"/>
+            <a:r>
+              <a:rPr sz="1300">
+                <a:solidFill>
+                  <a:srgbClr val="FFFFFF"/>
+                </a:solidFill>
+                <a:latin typeface="Aptos Mono"/>
+              </a:rPr>
               <a:t> 2    ("preprocess", preprocessor),</a:t>
             </a:r>
-            <a:br/>
-            <a:r>
+          </a:p>
+          <a:p>
+            <a:pPr algn="l"/>
+            <a:r>
+              <a:rPr sz="1300">
+                <a:solidFill>
+                  <a:srgbClr val="FFFFFF"/>
+                </a:solidFill>
+                <a:latin typeface="Aptos Mono"/>
+              </a:rPr>
               <a:t> 3    ("tree", DecisionTreeClassifier(</a:t>
             </a:r>
-            <a:br/>
-            <a:r>
+          </a:p>
+          <a:p>
+            <a:pPr algn="l"/>
+            <a:r>
+              <a:rPr sz="1300">
+                <a:solidFill>
+                  <a:srgbClr val="FFFFFF"/>
+                </a:solidFill>
+                <a:latin typeface="Aptos Mono"/>
+              </a:rPr>
               <a:t> 4        criterion="entropy",</a:t>
             </a:r>
-            <a:br/>
-            <a:r>
-              <a:t> 5        max_depth=3,</a:t>
-            </a:r>
-            <a:br/>
-            <a:r>
-              <a:t> 6        random_state=42</a:t>
-            </a:r>
-            <a:br/>
-            <a:r>
+          </a:p>
+          <a:p>
+            <a:pPr algn="l"/>
+            <a:r>
+              <a:rPr sz="1300">
+                <a:solidFill>
+                  <a:srgbClr val="FFFFFF"/>
+                </a:solidFill>
+                <a:latin typeface="Aptos Mono"/>
+              </a:rPr>
+              <a:t> 5        max_depth=MAX_DEPTH,</a:t>
+            </a:r>
+          </a:p>
+          <a:p>
+            <a:pPr algn="l"/>
+            <a:r>
+              <a:rPr sz="1300">
+                <a:solidFill>
+                  <a:srgbClr val="FFFFFF"/>
+                </a:solidFill>
+                <a:latin typeface="Aptos Mono"/>
+              </a:rPr>
+              <a:t> 6        random_state=RANDOM_STATE</a:t>
+            </a:r>
+          </a:p>
+          <a:p>
+            <a:pPr algn="l"/>
+            <a:r>
+              <a:rPr sz="1300">
+                <a:solidFill>
+                  <a:srgbClr val="FFFFFF"/>
+                </a:solidFill>
+                <a:latin typeface="Aptos Mono"/>
+              </a:rPr>
               <a:t> 7    ))</a:t>
             </a:r>
-            <a:br/>
-            <a:r>
+          </a:p>
+          <a:p>
+            <a:pPr algn="l"/>
+            <a:r>
+              <a:rPr sz="1300">
+                <a:solidFill>
+                  <a:srgbClr val="FFFFFF"/>
+                </a:solidFill>
+                <a:latin typeface="Aptos Mono"/>
+              </a:rPr>
               <a:t> 8  ])</a:t>
             </a:r>
-            <a:br/>
-            <a:r>
+          </a:p>
+          <a:p>
+            <a:pPr algn="l"/>
+            <a:r>
+              <a:rPr sz="1300">
+                <a:solidFill>
+                  <a:srgbClr val="FFFFFF"/>
+                </a:solidFill>
+                <a:latin typeface="Aptos Mono"/>
+              </a:rPr>
               <a:t> 9  model.fit(X_train, y_train)</a:t>
             </a:r>
           </a:p>
@@ -5036,7 +5235,8 @@
               </a:defRPr>
             </a:pPr>
             <a:r>
-              <a:t>Example: DURATION ≤ 21?</a:t>
+              <a:rPr/>
+              <a:t>Example: one candidate question from the current data</a:t>
             </a:r>
           </a:p>
         </p:txBody>
@@ -5360,7 +5560,8 @@
               </a:defRPr>
             </a:pPr>
             <a:r>
-              <a:t>Stop at max_depth = 3 in this demo.</a:t>
+              <a:rPr/>
+              <a:t>Stop at the configured MAX_DEPTH in this demo.</a:t>
             </a:r>
           </a:p>
         </p:txBody>
@@ -5857,26 +6058,63 @@
               </a:defRPr>
             </a:pPr>
             <a:r>
+              <a:rPr/>
               <a:t>1  Applies preprocessing and the fitted tree to unseen test rows.</a:t>
             </a:r>
-            <a:br/>
-            <a:br/>
-            <a:r>
+          </a:p>
+          <a:p>
+            <a:pPr algn="l"/>
+            <a:r>
+              <a:rPr/>
+              <a:t/>
+            </a:r>
+          </a:p>
+          <a:p>
+            <a:pPr algn="l"/>
+            <a:r>
+              <a:rPr/>
               <a:t>2  Calculates the overall correct share.</a:t>
             </a:r>
-            <a:br/>
-            <a:br/>
-            <a:r>
-              <a:t>3  Averages recall across the two classes.</a:t>
-            </a:r>
-            <a:br/>
-            <a:br/>
-            <a:r>
+          </a:p>
+          <a:p>
+            <a:pPr algn="l"/>
+            <a:r>
+              <a:rPr/>
+              <a:t/>
+            </a:r>
+          </a:p>
+          <a:p>
+            <a:pPr algn="l"/>
+            <a:r>
+              <a:rPr/>
+              <a:t>3  Averages recall across all target classes.</a:t>
+            </a:r>
+          </a:p>
+          <a:p>
+            <a:pPr algn="l"/>
+            <a:r>
+              <a:rPr/>
+              <a:t/>
+            </a:r>
+          </a:p>
+          <a:p>
+            <a:pPr algn="l"/>
+            <a:r>
+              <a:rPr/>
               <a:t>4  Reports precision, recall, and F1 for each class.</a:t>
             </a:r>
-            <a:br/>
-            <a:br/>
-            <a:r>
+          </a:p>
+          <a:p>
+            <a:pPr algn="l"/>
+            <a:r>
+              <a:rPr/>
+              <a:t/>
+            </a:r>
+          </a:p>
+          <a:p>
+            <a:pPr algn="l"/>
+            <a:r>
+              <a:rPr/>
               <a:t>Use several views; no single metric tells the whole story.</a:t>
             </a:r>
           </a:p>
@@ -6010,7 +6248,8 @@
               </a:defRPr>
             </a:pPr>
             <a:r>
-              <a:t>Holdout results</a:t>
+              <a:rPr/>
+              <a:t>Default Credit example: holdout results</a:t>
             </a:r>
           </a:p>
         </p:txBody>
@@ -6955,30 +7194,84 @@
               </a:defRPr>
             </a:pPr>
             <a:r>
-              <a:t> 1  ConfusionMatrixDisplay.from_predictions(</a:t>
-            </a:r>
-            <a:br/>
-            <a:r>
-              <a:t> 2      y_test, y_pred,</a:t>
-            </a:r>
-            <a:br/>
-            <a:r>
-              <a:t> 3      labels=[0, 1],</a:t>
-            </a:r>
-            <a:br/>
-            <a:r>
-              <a:t> 4      cmap="Reds",</a:t>
-            </a:r>
-            <a:br/>
-            <a:r>
-              <a:t> 5      colorbar=False</a:t>
-            </a:r>
-            <a:br/>
-            <a:r>
+              <a:rPr sz="1300">
+                <a:solidFill>
+                  <a:srgbClr val="FFFFFF"/>
+                </a:solidFill>
+                <a:latin typeface="Aptos Mono"/>
+              </a:rPr>
+              <a:t> 1  class_labels = list(tree_model.classes_)</a:t>
+            </a:r>
+          </a:p>
+          <a:p>
+            <a:pPr algn="l"/>
+            <a:r>
+              <a:rPr sz="1300">
+                <a:solidFill>
+                  <a:srgbClr val="FFFFFF"/>
+                </a:solidFill>
+                <a:latin typeface="Aptos Mono"/>
+              </a:rPr>
+              <a:t> 2  ConfusionMatrixDisplay.from_predictions(</a:t>
+            </a:r>
+          </a:p>
+          <a:p>
+            <a:pPr algn="l"/>
+            <a:r>
+              <a:rPr sz="1300">
+                <a:solidFill>
+                  <a:srgbClr val="FFFFFF"/>
+                </a:solidFill>
+                <a:latin typeface="Aptos Mono"/>
+              </a:rPr>
+              <a:t> 3      y_test, y_pred,</a:t>
+            </a:r>
+          </a:p>
+          <a:p>
+            <a:pPr algn="l"/>
+            <a:r>
+              <a:rPr sz="1300">
+                <a:solidFill>
+                  <a:srgbClr val="FFFFFF"/>
+                </a:solidFill>
+                <a:latin typeface="Aptos Mono"/>
+              </a:rPr>
+              <a:t> 4      labels=class_labels,</a:t>
+            </a:r>
+          </a:p>
+          <a:p>
+            <a:pPr algn="l"/>
+            <a:r>
+              <a:rPr sz="1300">
+                <a:solidFill>
+                  <a:srgbClr val="FFFFFF"/>
+                </a:solidFill>
+                <a:latin typeface="Aptos Mono"/>
+              </a:rPr>
+              <a:t> 5      cmap="Reds", colorbar=False</a:t>
+            </a:r>
+          </a:p>
+          <a:p>
+            <a:pPr algn="l"/>
+            <a:r>
+              <a:rPr sz="1300">
+                <a:solidFill>
+                  <a:srgbClr val="FFFFFF"/>
+                </a:solidFill>
+                <a:latin typeface="Aptos Mono"/>
+              </a:rPr>
               <a:t> 6  )</a:t>
             </a:r>
-            <a:br/>
-            <a:r>
+          </a:p>
+          <a:p>
+            <a:pPr algn="l"/>
+            <a:r>
+              <a:rPr sz="1300">
+                <a:solidFill>
+                  <a:srgbClr val="FFFFFF"/>
+                </a:solidFill>
+                <a:latin typeface="Aptos Mono"/>
+              </a:rPr>
               <a:t> 7  plt.show()</a:t>
             </a:r>
           </a:p>
@@ -7015,26 +7308,49 @@
               </a:defRPr>
             </a:pPr>
             <a:r>
-              <a:t>1–2  Compares actual and predicted classes.</a:t>
-            </a:r>
-            <a:br/>
-            <a:br/>
-            <a:r>
-              <a:t>3  Fixes a clear class order.</a:t>
-            </a:r>
-            <a:br/>
-            <a:br/>
-            <a:r>
-              <a:t>4–5  Controls the chart appearance.</a:t>
-            </a:r>
-            <a:br/>
-            <a:br/>
-            <a:r>
-              <a:t>6–7  Completes and displays the chart.</a:t>
-            </a:r>
-            <a:br/>
-            <a:br/>
-            <a:r>
+              <a:rPr/>
+              <a:t>1  Reads the target labels learned from the current dataset.</a:t>
+            </a:r>
+          </a:p>
+          <a:p>
+            <a:pPr algn="l"/>
+            <a:r>
+              <a:rPr/>
+              <a:t/>
+            </a:r>
+          </a:p>
+          <a:p>
+            <a:pPr algn="l"/>
+            <a:r>
+              <a:rPr/>
+              <a:t>2–4  Compares actual and predicted classes in a fixed order.</a:t>
+            </a:r>
+          </a:p>
+          <a:p>
+            <a:pPr algn="l"/>
+            <a:r>
+              <a:rPr/>
+              <a:t/>
+            </a:r>
+          </a:p>
+          <a:p>
+            <a:pPr algn="l"/>
+            <a:r>
+              <a:rPr/>
+              <a:t>5–7  Controls and displays the chart.</a:t>
+            </a:r>
+          </a:p>
+          <a:p>
+            <a:pPr algn="l"/>
+            <a:r>
+              <a:rPr/>
+              <a:t/>
+            </a:r>
+          </a:p>
+          <a:p>
+            <a:pPr algn="l"/>
+            <a:r>
+              <a:rPr/>
               <a:t>Rows are actual classes; columns are predicted classes.</a:t>
             </a:r>
           </a:p>
@@ -7168,7 +7484,8 @@
               </a:defRPr>
             </a:pPr>
             <a:r>
-              <a:t>Where did the model make errors?</a:t>
+              <a:rPr/>
+              <a:t>Default Credit example: where are the errors?</a:t>
             </a:r>
           </a:p>
         </p:txBody>
@@ -7509,7 +7826,8 @@
               </a:defRPr>
             </a:pPr>
             <a:r>
-              <a:t>Business error costs require the verified class mapping.</a:t>
+              <a:rPr/>
+              <a:t>For a new dataset, interpret errors using its own class meanings and decision costs.</a:t>
             </a:r>
           </a:p>
         </p:txBody>
@@ -7879,34 +8197,96 @@
               </a:defRPr>
             </a:pPr>
             <a:r>
+              <a:rPr sz="1200">
+                <a:solidFill>
+                  <a:srgbClr val="FFFFFF"/>
+                </a:solidFill>
+                <a:latin typeface="Aptos Mono"/>
+              </a:rPr>
               <a:t> 1  tree_model = model.named_steps["tree"]</a:t>
             </a:r>
-            <a:br/>
-            <a:r>
+          </a:p>
+          <a:p>
+            <a:pPr algn="l"/>
+            <a:r>
+              <a:rPr sz="1200">
+                <a:solidFill>
+                  <a:srgbClr val="FFFFFF"/>
+                </a:solidFill>
+                <a:latin typeface="Aptos Mono"/>
+              </a:rPr>
               <a:t> 2  feature_names = model.named_steps["preprocess"]</a:t>
             </a:r>
-            <a:br/>
-            <a:r>
+          </a:p>
+          <a:p>
+            <a:pPr algn="l"/>
+            <a:r>
+              <a:rPr sz="1200">
+                <a:solidFill>
+                  <a:srgbClr val="FFFFFF"/>
+                </a:solidFill>
+                <a:latin typeface="Aptos Mono"/>
+              </a:rPr>
               <a:t> 3      .get_feature_names_out()</a:t>
             </a:r>
-            <a:br/>
-            <a:r>
+          </a:p>
+          <a:p>
+            <a:pPr algn="l"/>
+            <a:r>
+              <a:rPr sz="1200">
+                <a:solidFill>
+                  <a:srgbClr val="FFFFFF"/>
+                </a:solidFill>
+                <a:latin typeface="Aptos Mono"/>
+              </a:rPr>
               <a:t> 4  plot_tree(tree_model,</a:t>
             </a:r>
-            <a:br/>
-            <a:r>
+          </a:p>
+          <a:p>
+            <a:pPr algn="l"/>
+            <a:r>
+              <a:rPr sz="1200">
+                <a:solidFill>
+                  <a:srgbClr val="FFFFFF"/>
+                </a:solidFill>
+                <a:latin typeface="Aptos Mono"/>
+              </a:rPr>
               <a:t> 5      feature_names=feature_names,</a:t>
             </a:r>
-            <a:br/>
-            <a:r>
-              <a:t> 6      class_names=["0", "1"],</a:t>
-            </a:r>
-            <a:br/>
-            <a:r>
+          </a:p>
+          <a:p>
+            <a:pPr algn="l"/>
+            <a:r>
+              <a:rPr sz="1200">
+                <a:solidFill>
+                  <a:srgbClr val="FFFFFF"/>
+                </a:solidFill>
+                <a:latin typeface="Aptos Mono"/>
+              </a:rPr>
+              <a:t> 6      class_names=[str(v) for v in tree_model.classes_],</a:t>
+            </a:r>
+          </a:p>
+          <a:p>
+            <a:pPr algn="l"/>
+            <a:r>
+              <a:rPr sz="1200">
+                <a:solidFill>
+                  <a:srgbClr val="FFFFFF"/>
+                </a:solidFill>
+                <a:latin typeface="Aptos Mono"/>
+              </a:rPr>
               <a:t> 7      filled=True, rounded=True</a:t>
             </a:r>
-            <a:br/>
-            <a:r>
+          </a:p>
+          <a:p>
+            <a:pPr algn="l"/>
+            <a:r>
+              <a:rPr sz="1200">
+                <a:solidFill>
+                  <a:srgbClr val="FFFFFF"/>
+                </a:solidFill>
+                <a:latin typeface="Aptos Mono"/>
+              </a:rPr>
               <a:t> 8  )</a:t>
             </a:r>
           </a:p>
@@ -8629,7 +9009,8 @@
               </a:defRPr>
             </a:pPr>
             <a:r>
-              <a:t>Read the Credit CSV into a pandas DataFrame</a:t>
+              <a:rPr/>
+              <a:t>Read the example or upload any classification CSV</a:t>
             </a:r>
           </a:p>
         </p:txBody>
@@ -8780,7 +9161,8 @@
               </a:defRPr>
             </a:pPr>
             <a:r>
-              <a:t>Separate the target, encode categories, and split the data</a:t>
+              <a:rPr/>
+              <a:t>Configure column roles, handle missing data, and split</a:t>
             </a:r>
           </a:p>
         </p:txBody>
@@ -9769,7 +10151,8 @@
               </a:defRPr>
             </a:pPr>
             <a:r>
-              <a:t>Counts of class 0 and class 1 at the node.</a:t>
+              <a:rPr/>
+              <a:t>Counts for every target class at that node.</a:t>
             </a:r>
           </a:p>
         </p:txBody>
@@ -10737,55 +11120,29 @@
               </a:defRPr>
             </a:pPr>
             <a:r>
-              <a:t>•  Class 0 is much less frequent than class 1.</a:t>
-            </a:r>
-          </a:p>
-          <a:p>
-            <a:pPr>
-              <a:spcAft>
-                <a:spcPts val="700"/>
-              </a:spcAft>
-              <a:defRPr sz="1700">
-                <a:solidFill>
-                  <a:srgbClr val="1A1F24"/>
-                </a:solidFill>
-                <a:latin typeface="Aptos"/>
-              </a:defRPr>
-            </a:pPr>
-            <a:r>
-              <a:t>•  Balanced weights make minority-class mistakes matter more during training.</a:t>
-            </a:r>
-          </a:p>
-          <a:p>
-            <a:pPr>
-              <a:spcAft>
-                <a:spcPts val="700"/>
-              </a:spcAft>
-              <a:defRPr sz="1700">
-                <a:solidFill>
-                  <a:srgbClr val="1A1F24"/>
-                </a:solidFill>
-                <a:latin typeface="Aptos"/>
-              </a:defRPr>
-            </a:pPr>
-            <a:r>
-              <a:t>•  The tradeoff may shift—not disappear.</a:t>
-            </a:r>
-          </a:p>
-          <a:p>
-            <a:pPr>
-              <a:spcAft>
-                <a:spcPts val="700"/>
-              </a:spcAft>
-              <a:defRPr sz="1700">
-                <a:solidFill>
-                  <a:srgbClr val="1A1F24"/>
-                </a:solidFill>
-                <a:latin typeface="Aptos"/>
-              </a:defRPr>
-            </a:pPr>
-            <a:r>
-              <a:t>•  Choose using business costs and stronger validation, not one tiny test split.</a:t>
+              <a:rPr/>
+              <a:t>•  Try weighting when one or more classes are much less frequent.</a:t>
+            </a:r>
+          </a:p>
+          <a:p>
+            <a:pPr/>
+            <a:r>
+              <a:rPr/>
+              <a:t>•  Minority-class mistakes receive more influence during training.</a:t>
+            </a:r>
+          </a:p>
+          <a:p>
+            <a:pPr/>
+            <a:r>
+              <a:rPr/>
+              <a:t>•  The error tradeoff may shift—not disappear.</a:t>
+            </a:r>
+          </a:p>
+          <a:p>
+            <a:pPr/>
+            <a:r>
+              <a:rPr/>
+              <a:t>•  Compare using decision costs and stronger validation.</a:t>
             </a:r>
           </a:p>
         </p:txBody>
@@ -10864,7 +11221,8 @@
               </a:defRPr>
             </a:pPr>
             <a:r>
-              <a:t>Experimentation is for learning; it does not turn this dataset into a deployable lending model.</a:t>
+              <a:rPr/>
+              <a:t>Class weighting is an experiment, not an automatic improvement.</a:t>
             </a:r>
           </a:p>
         </p:txBody>
@@ -10997,7 +11355,8 @@
               </a:defRPr>
             </a:pPr>
             <a:r>
-              <a:t>What should we conclude?</a:t>
+              <a:rPr/>
+              <a:t>What must students reconsider for new data?</a:t>
             </a:r>
           </a:p>
         </p:txBody>
@@ -11148,7 +11507,8 @@
               </a:defRPr>
             </a:pPr>
             <a:r>
-              <a:t>Small sample</a:t>
+              <a:rPr/>
+              <a:t>Problem meaning</a:t>
             </a:r>
           </a:p>
         </p:txBody>
@@ -11184,7 +11544,8 @@
               </a:defRPr>
             </a:pPr>
             <a:r>
-              <a:t>59 rows and only 12 test cases make results unstable.</a:t>
+              <a:rPr/>
+              <a:t>Define one row, the target, prediction timing, and decision use.</a:t>
             </a:r>
           </a:p>
         </p:txBody>
@@ -11220,7 +11581,8 @@
               </a:defRPr>
             </a:pPr>
             <a:r>
-              <a:t>Imbalance</a:t>
+              <a:rPr/>
+              <a:t>Column roles</a:t>
             </a:r>
           </a:p>
         </p:txBody>
@@ -11256,7 +11618,8 @@
               </a:defRPr>
             </a:pPr>
             <a:r>
-              <a:t>The majority class dominates ordinary accuracy.</a:t>
+              <a:rPr/>
+              <a:t>Remove IDs and leakage; identify coded categories correctly.</a:t>
             </a:r>
           </a:p>
         </p:txBody>
@@ -11292,7 +11655,8 @@
               </a:defRPr>
             </a:pPr>
             <a:r>
-              <a:t>Unknown labels</a:t>
+              <a:rPr/>
+              <a:t>Sample and balance</a:t>
             </a:r>
           </a:p>
         </p:txBody>
@@ -11328,7 +11692,8 @@
               </a:defRPr>
             </a:pPr>
             <a:r>
-              <a:t>The CSV does not verify which value means Good or Bad.</a:t>
+              <a:rPr/>
+              <a:t>Check whether every class has enough training and test rows.</a:t>
             </a:r>
           </a:p>
         </p:txBody>
@@ -11364,7 +11729,8 @@
               </a:defRPr>
             </a:pPr>
             <a:r>
-              <a:t>Code mismatch</a:t>
+              <a:rPr/>
+              <a:t>Error meaning</a:t>
             </a:r>
           </a:p>
         </p:txBody>
@@ -11400,7 +11766,8 @@
               </a:defRPr>
             </a:pPr>
             <a:r>
-              <a:t>Legacy category descriptions do not match the CSV coding.</a:t>
+              <a:rPr/>
+              <a:t>Interpret each confusion-matrix error in the new context.</a:t>
             </a:r>
           </a:p>
         </p:txBody>
@@ -11436,7 +11803,8 @@
               </a:defRPr>
             </a:pPr>
             <a:r>
-              <a:t>High-impact use</a:t>
+              <a:rPr/>
+              <a:t>Limitations</a:t>
             </a:r>
           </a:p>
         </p:txBody>
@@ -11472,7 +11840,8 @@
               </a:defRPr>
             </a:pPr>
             <a:r>
-              <a:t>Real lending requires fairness, compliance, monitoring, and far stronger validation.</a:t>
+              <a:rPr/>
+              <a:t>Discuss data quality, bias, stability, and deployment risks.</a:t>
             </a:r>
           </a:p>
         </p:txBody>
@@ -12314,7 +12683,8 @@
               </a:defRPr>
             </a:pPr>
             <a:r>
-              <a:t>Run the demo in Google Colab</a:t>
+              <a:rPr/>
+              <a:t>Repeat the workflow with another dataset</a:t>
             </a:r>
           </a:p>
         </p:txBody>
@@ -12468,55 +12838,29 @@
               </a:defRPr>
             </a:pPr>
             <a:r>
-              <a:t>•  Open the notebook using the Colab link below.</a:t>
-            </a:r>
-          </a:p>
-          <a:p>
-            <a:pPr>
-              <a:spcAft>
-                <a:spcPts val="700"/>
-              </a:spcAft>
-              <a:defRPr sz="1800">
-                <a:solidFill>
-                  <a:srgbClr val="1A1F24"/>
-                </a:solidFill>
-                <a:latin typeface="Aptos"/>
-              </a:defRPr>
-            </a:pPr>
-            <a:r>
-              <a:t>•  Keep UPLOAD_FILE = False to read from GitHub, or change it to True to upload Credit.csv.</a:t>
-            </a:r>
-          </a:p>
-          <a:p>
-            <a:pPr>
-              <a:spcAft>
-                <a:spcPts val="700"/>
-              </a:spcAft>
-              <a:defRPr sz="1800">
-                <a:solidFill>
-                  <a:srgbClr val="1A1F24"/>
-                </a:solidFill>
-                <a:latin typeface="Aptos"/>
-              </a:defRPr>
-            </a:pPr>
-            <a:r>
-              <a:t>•  Select Runtime → Run all.</a:t>
-            </a:r>
-          </a:p>
-          <a:p>
-            <a:pPr>
-              <a:spcAft>
-                <a:spcPts val="700"/>
-              </a:spcAft>
-              <a:defRPr sz="1800">
-                <a:solidFill>
-                  <a:srgbClr val="1A1F24"/>
-                </a:solidFill>
-                <a:latin typeface="Aptos"/>
-              </a:defRPr>
-            </a:pPr>
-            <a:r>
-              <a:t>•  Use File → Save a copy in Drive before editing or sharing with students.</a:t>
+              <a:rPr/>
+              <a:t>•  First run the Credit example from GitHub.</a:t>
+            </a:r>
+          </a:p>
+          <a:p>
+            <a:pPr/>
+            <a:r>
+              <a:rPr/>
+              <a:t>•  Change UPLOAD_FILE = True and upload another classification CSV.</a:t>
+            </a:r>
+          </a:p>
+          <a:p>
+            <a:pPr/>
+            <a:r>
+              <a:rPr/>
+              <a:t>•  Edit only the Section 4 settings: target, IDs, and categorical columns.</a:t>
+            </a:r>
+          </a:p>
+          <a:p>
+            <a:pPr/>
+            <a:r>
+              <a:rPr/>
+              <a:t>•  Select Runtime → Run all, then interpret every new output.</a:t>
             </a:r>
           </a:p>
         </p:txBody>
@@ -12667,7 +13011,8 @@
               </a:defRPr>
             </a:pPr>
             <a:r>
-              <a:t>Teaching tip: pause before each output and ask students to predict what they expect to see.</a:t>
+              <a:rPr/>
+              <a:t>Student deliverable: business question, settings, data audit, model, evaluation, interpretation, and limitations.</a:t>
             </a:r>
           </a:p>
         </p:txBody>
@@ -12800,7 +13145,8 @@
               </a:defRPr>
             </a:pPr>
             <a:r>
-              <a:t>Business problem and data</a:t>
+              <a:rPr/>
+              <a:t>Reusable workflow with a Credit example</a:t>
             </a:r>
           </a:p>
         </p:txBody>
@@ -12987,7 +13333,8 @@
               </a:defRPr>
             </a:pPr>
             <a:r>
-              <a:t>Predict the recorded CREDIT class from an applicant profile as a bank decision-support example.</a:t>
+              <a:rPr/>
+              <a:t>For any dataset: define one row, the target category, available predictors, and how the prediction will be used.</a:t>
             </a:r>
           </a:p>
         </p:txBody>
@@ -13066,7 +13413,8 @@
               </a:defRPr>
             </a:pPr>
             <a:r>
-              <a:t>Supervised learning: the known CREDIT label teaches the model.</a:t>
+              <a:rPr/>
+              <a:t>Credit.csv is the worked example; students repeat the workflow with another classification dataset.</a:t>
             </a:r>
           </a:p>
         </p:txBody>
@@ -13499,7 +13847,8 @@
               </a:defRPr>
             </a:pPr>
             <a:r>
-              <a:t>Do not translate 0/1 into Good/Bad until a matching data dictionary verifies the mapping.</a:t>
+              <a:rPr/>
+              <a:t>Every new dataset needs its own verified column meanings and target definition.</a:t>
             </a:r>
           </a:p>
         </p:txBody>
@@ -13869,43 +14218,133 @@
               </a:defRPr>
             </a:pPr>
             <a:r>
+              <a:rPr sz="1200">
+                <a:solidFill>
+                  <a:srgbClr val="FFFFFF"/>
+                </a:solidFill>
+                <a:latin typeface="Aptos Mono"/>
+              </a:rPr>
               <a:t> 1  import io</a:t>
             </a:r>
-            <a:br/>
-            <a:r>
+          </a:p>
+          <a:p>
+            <a:pPr algn="l"/>
+            <a:r>
+              <a:rPr sz="1200">
+                <a:solidFill>
+                  <a:srgbClr val="FFFFFF"/>
+                </a:solidFill>
+                <a:latin typeface="Aptos Mono"/>
+              </a:rPr>
               <a:t> 2  from pathlib import Path</a:t>
             </a:r>
-            <a:br/>
-            <a:r>
+          </a:p>
+          <a:p>
+            <a:pPr algn="l"/>
+            <a:r>
+              <a:rPr sz="1200">
+                <a:solidFill>
+                  <a:srgbClr val="FFFFFF"/>
+                </a:solidFill>
+                <a:latin typeface="Aptos Mono"/>
+              </a:rPr>
               <a:t> 3  import matplotlib.pyplot as plt</a:t>
             </a:r>
-            <a:br/>
-            <a:r>
+          </a:p>
+          <a:p>
+            <a:pPr algn="l"/>
+            <a:r>
+              <a:rPr sz="1200">
+                <a:solidFill>
+                  <a:srgbClr val="FFFFFF"/>
+                </a:solidFill>
+                <a:latin typeface="Aptos Mono"/>
+              </a:rPr>
               <a:t> 4  import pandas as pd</a:t>
             </a:r>
-            <a:br/>
-            <a:r>
+          </a:p>
+          <a:p>
+            <a:pPr algn="l"/>
+            <a:r>
+              <a:rPr sz="1200">
+                <a:solidFill>
+                  <a:srgbClr val="FFFFFF"/>
+                </a:solidFill>
+                <a:latin typeface="Aptos Mono"/>
+              </a:rPr>
               <a:t> 5  from sklearn.compose import ColumnTransformer</a:t>
             </a:r>
-            <a:br/>
-            <a:r>
-              <a:t> 6  from sklearn.metrics import (...) </a:t>
-            </a:r>
-            <a:br/>
-            <a:r>
-              <a:t> 7  from sklearn.model_selection import train_test_split</a:t>
-            </a:r>
-            <a:br/>
-            <a:r>
-              <a:t> 8  from sklearn.pipeline import Pipeline</a:t>
-            </a:r>
-            <a:br/>
-            <a:r>
-              <a:t> 9  from sklearn.preprocessing import OneHotEncoder</a:t>
-            </a:r>
-            <a:br/>
-            <a:r>
-              <a:t>10  from sklearn.tree import DecisionTreeClassifier, plot_tree</a:t>
+          </a:p>
+          <a:p>
+            <a:pPr algn="l"/>
+            <a:r>
+              <a:rPr sz="1200">
+                <a:solidFill>
+                  <a:srgbClr val="FFFFFF"/>
+                </a:solidFill>
+                <a:latin typeface="Aptos Mono"/>
+              </a:rPr>
+              <a:t> 6  from sklearn.impute import SimpleImputer</a:t>
+            </a:r>
+          </a:p>
+          <a:p>
+            <a:pPr algn="l"/>
+            <a:r>
+              <a:rPr sz="1200">
+                <a:solidFill>
+                  <a:srgbClr val="FFFFFF"/>
+                </a:solidFill>
+                <a:latin typeface="Aptos Mono"/>
+              </a:rPr>
+              <a:t> 7  from sklearn.metrics import (...)</a:t>
+            </a:r>
+          </a:p>
+          <a:p>
+            <a:pPr algn="l"/>
+            <a:r>
+              <a:rPr sz="1200">
+                <a:solidFill>
+                  <a:srgbClr val="FFFFFF"/>
+                </a:solidFill>
+                <a:latin typeface="Aptos Mono"/>
+              </a:rPr>
+              <a:t> 8  from sklearn.model_selection import train_test_split</a:t>
+            </a:r>
+          </a:p>
+          <a:p>
+            <a:pPr algn="l"/>
+            <a:r>
+              <a:rPr sz="1200">
+                <a:solidFill>
+                  <a:srgbClr val="FFFFFF"/>
+                </a:solidFill>
+                <a:latin typeface="Aptos Mono"/>
+              </a:rPr>
+              <a:t> 9  from sklearn.pipeline import Pipeline</a:t>
+            </a:r>
+          </a:p>
+          <a:p>
+            <a:pPr algn="l"/>
+            <a:r>
+              <a:rPr sz="1200">
+                <a:solidFill>
+                  <a:srgbClr val="FFFFFF"/>
+                </a:solidFill>
+                <a:latin typeface="Aptos Mono"/>
+              </a:rPr>
+              <a:t>10  from sklearn.preprocessing import OneHotEncoder</a:t>
+            </a:r>
+          </a:p>
+          <a:p>
+            <a:pPr algn="l"/>
+            <a:r>
+              <a:rPr sz="1200">
+                <a:solidFill>
+                  <a:srgbClr val="FFFFFF"/>
+                </a:solidFill>
+                <a:latin typeface="Aptos Mono"/>
+              </a:rPr>
+              <a:t>11  from sklearn.tree import DecisionTreeClassifier, plot_tree</a:t>
             </a:r>
           </a:p>
         </p:txBody>
@@ -13941,37 +14380,78 @@
               </a:defRPr>
             </a:pPr>
             <a:r>
+              <a:rPr/>
               <a:t>1–2  Support uploaded files and local paths.</a:t>
             </a:r>
-            <a:br/>
-            <a:br/>
-            <a:r>
-              <a:t>3  Creates charts.</a:t>
-            </a:r>
-            <a:br/>
-            <a:br/>
-            <a:r>
-              <a:t>4  Loads and summarizes tabular data.</a:t>
-            </a:r>
-            <a:br/>
-            <a:br/>
-            <a:r>
-              <a:t>5, 8–9  Build a reusable preprocessing-and-model workflow.</a:t>
-            </a:r>
-            <a:br/>
-            <a:br/>
-            <a:r>
-              <a:t>6  Imports evaluation tools.</a:t>
-            </a:r>
-            <a:br/>
-            <a:br/>
-            <a:r>
-              <a:t>7  Creates training and testing samples.</a:t>
-            </a:r>
-            <a:br/>
-            <a:br/>
-            <a:r>
-              <a:t>10  Imports the tree model and plot.</a:t>
+          </a:p>
+          <a:p>
+            <a:pPr algn="l"/>
+            <a:r>
+              <a:rPr/>
+              <a:t/>
+            </a:r>
+          </a:p>
+          <a:p>
+            <a:pPr algn="l"/>
+            <a:r>
+              <a:rPr/>
+              <a:t>3–4  Create charts and work with tables.</a:t>
+            </a:r>
+          </a:p>
+          <a:p>
+            <a:pPr algn="l"/>
+            <a:r>
+              <a:rPr/>
+              <a:t/>
+            </a:r>
+          </a:p>
+          <a:p>
+            <a:pPr algn="l"/>
+            <a:r>
+              <a:rPr/>
+              <a:t>5–6, 9–10  Build reusable preprocessing, including missing values and categories.</a:t>
+            </a:r>
+          </a:p>
+          <a:p>
+            <a:pPr algn="l"/>
+            <a:r>
+              <a:rPr/>
+              <a:t/>
+            </a:r>
+          </a:p>
+          <a:p>
+            <a:pPr algn="l"/>
+            <a:r>
+              <a:rPr/>
+              <a:t>7  Imports evaluation tools.</a:t>
+            </a:r>
+          </a:p>
+          <a:p>
+            <a:pPr algn="l"/>
+            <a:r>
+              <a:rPr/>
+              <a:t/>
+            </a:r>
+          </a:p>
+          <a:p>
+            <a:pPr algn="l"/>
+            <a:r>
+              <a:rPr/>
+              <a:t>8  Creates training and testing samples.</a:t>
+            </a:r>
+          </a:p>
+          <a:p>
+            <a:pPr algn="l"/>
+            <a:r>
+              <a:rPr/>
+              <a:t/>
+            </a:r>
+          </a:p>
+          <a:p>
+            <a:pPr algn="l"/>
+            <a:r>
+              <a:rPr/>
+              <a:t>11  Imports the tree model and plot.</a:t>
             </a:r>
           </a:p>
         </p:txBody>
@@ -14104,7 +14584,8 @@
               </a:defRPr>
             </a:pPr>
             <a:r>
-              <a:t>Choose how to load the CSV</a:t>
+              <a:rPr/>
+              <a:t>Choose the example or upload your CSV</a:t>
             </a:r>
           </a:p>
         </p:txBody>
@@ -14341,10 +14822,24 @@
               </a:defRPr>
             </a:pPr>
             <a:r>
-              <a:t> 1  raw_url = "https://raw.githubusercontent.com/.../Credit.csv"</a:t>
-            </a:r>
-            <a:br/>
-            <a:r>
+              <a:rPr sz="1400">
+                <a:solidFill>
+                  <a:srgbClr val="FFFFFF"/>
+                </a:solidFill>
+                <a:latin typeface="Aptos Mono"/>
+              </a:rPr>
+              <a:t> 1  EXAMPLE_URL = "https://raw.githubusercontent.com/.../Credit.csv"</a:t>
+            </a:r>
+          </a:p>
+          <a:p>
+            <a:pPr algn="l"/>
+            <a:r>
+              <a:rPr sz="1400">
+                <a:solidFill>
+                  <a:srgbClr val="FFFFFF"/>
+                </a:solidFill>
+                <a:latin typeface="Aptos Mono"/>
+              </a:rPr>
               <a:t> 2  UPLOAD_FILE = False</a:t>
             </a:r>
           </a:p>
@@ -14381,17 +14876,36 @@
               </a:defRPr>
             </a:pPr>
             <a:r>
-              <a:t>1  Stores the direct GitHub address of the CSV.</a:t>
-            </a:r>
-            <a:br/>
-            <a:br/>
-            <a:r>
-              <a:t>2  False loads from GitHub. Change to True to upload a file in Colab.</a:t>
-            </a:r>
-            <a:br/>
-            <a:br/>
-            <a:r>
-              <a:t>A local fallback lets the notebook also run beside Credit.csv.</a:t>
+              <a:rPr/>
+              <a:t>1  Stores the worked-example CSV address.</a:t>
+            </a:r>
+          </a:p>
+          <a:p>
+            <a:pPr algn="l"/>
+            <a:r>
+              <a:rPr/>
+              <a:t/>
+            </a:r>
+          </a:p>
+          <a:p>
+            <a:pPr algn="l"/>
+            <a:r>
+              <a:rPr/>
+              <a:t>2  False runs the example. Change to True to upload any classification CSV in Colab.</a:t>
+            </a:r>
+          </a:p>
+          <a:p>
+            <a:pPr algn="l"/>
+            <a:r>
+              <a:rPr/>
+              <a:t/>
+            </a:r>
+          </a:p>
+          <a:p>
+            <a:pPr algn="l"/>
+            <a:r>
+              <a:rPr/>
+              <a:t>Every choice creates the same DataFrame name: df.</a:t>
             </a:r>
           </a:p>
         </p:txBody>
@@ -14524,7 +15038,8 @@
               </a:defRPr>
             </a:pPr>
             <a:r>
-              <a:t>Load from GitHub or upload a file</a:t>
+              <a:rPr/>
+              <a:t>Create the reusable DataFrame named df</a:t>
             </a:r>
           </a:p>
         </p:txBody>
@@ -14825,22 +15340,50 @@
               </a:defRPr>
             </a:pPr>
             <a:r>
-              <a:t>1–4  When True, Colab displays a Choose Files button and reads the uploaded bytes.</a:t>
-            </a:r>
-            <a:br/>
-            <a:br/>
-            <a:r>
-              <a:t>5–6  Otherwise, pandas reads the GitHub CSV.</a:t>
-            </a:r>
-            <a:br/>
-            <a:br/>
-            <a:r>
-              <a:t>7  Confirms 59 rows × 10 columns.</a:t>
-            </a:r>
-            <a:br/>
-            <a:br/>
-            <a:r>
-              <a:t>8  Displays the first five records.</a:t>
+              <a:rPr/>
+              <a:t>1–4  When True, Colab displays a file button and reads the student's CSV.</a:t>
+            </a:r>
+          </a:p>
+          <a:p>
+            <a:pPr algn="l"/>
+            <a:r>
+              <a:rPr/>
+              <a:t/>
+            </a:r>
+          </a:p>
+          <a:p>
+            <a:pPr algn="l"/>
+            <a:r>
+              <a:rPr/>
+              <a:t>5–6  Otherwise, pandas reads the example.</a:t>
+            </a:r>
+          </a:p>
+          <a:p>
+            <a:pPr algn="l"/>
+            <a:r>
+              <a:rPr/>
+              <a:t/>
+            </a:r>
+          </a:p>
+          <a:p>
+            <a:pPr algn="l"/>
+            <a:r>
+              <a:rPr/>
+              <a:t>7  Reports the current dataset's shape.</a:t>
+            </a:r>
+          </a:p>
+          <a:p>
+            <a:pPr algn="l"/>
+            <a:r>
+              <a:rPr/>
+              <a:t/>
+            </a:r>
+          </a:p>
+          <a:p>
+            <a:pPr algn="l"/>
+            <a:r>
+              <a:rPr/>
+              <a:t>8  Displays its first five records.</a:t>
             </a:r>
           </a:p>
         </p:txBody>
@@ -14973,7 +15516,8 @@
               </a:defRPr>
             </a:pPr>
             <a:r>
-              <a:t>Check the loaded data</a:t>
+              <a:rPr/>
+              <a:t>Default example: check the loaded data</a:t>
             </a:r>
           </a:p>
         </p:txBody>
@@ -16363,7 +16907,8 @@
               </a:defRPr>
             </a:pPr>
             <a:r>
-              <a:t>Dataset shape: 59 rows × 10 columns</a:t>
+              <a:rPr/>
+              <a:t>Credit example shape: 59 rows × 10 columns</a:t>
             </a:r>
           </a:p>
         </p:txBody>
@@ -16460,7 +17005,8 @@
               </a:defRPr>
             </a:pPr>
             <a:r>
-              <a:t>STEP 4 · INSPECT</a:t>
+              <a:rPr/>
+              <a:t>STEP 4 · CONFIGURE DATA</a:t>
             </a:r>
           </a:p>
         </p:txBody>
@@ -16496,7 +17042,8 @@
               </a:defRPr>
             </a:pPr>
             <a:r>
-              <a:t>Check data quality and class balance</a:t>
+              <a:rPr/>
+              <a:t>Tell Python what each column means</a:t>
             </a:r>
           </a:p>
         </p:txBody>
@@ -16616,30 +17163,6 @@
           </a:p>
         </p:txBody>
       </p:sp>
-      <p:pic>
-        <p:nvPicPr>
-          <p:cNvPr id="8" name="Picture 7" descr="target_distribution.png"/>
-          <p:cNvPicPr>
-            <a:picLocks noChangeAspect="1"/>
-          </p:cNvPicPr>
-          <p:nvPr/>
-        </p:nvPicPr>
-        <p:blipFill>
-          <a:blip r:embed="rId2"/>
-          <a:stretch>
-            <a:fillRect/>
-          </a:stretch>
-        </p:blipFill>
-        <p:spPr>
-          <a:xfrm>
-            <a:off x="685800" y="1389888"/>
-            <a:ext cx="5897880" cy="2903572"/>
-          </a:xfrm>
-          <a:prstGeom prst="rect">
-            <a:avLst/>
-          </a:prstGeom>
-        </p:spPr>
-      </p:pic>
       <p:sp>
         <p:nvSpPr>
           <p:cNvPr id="9" name="TextBox 8"/>
@@ -16671,7 +17194,8 @@
               </a:defRPr>
             </a:pPr>
             <a:r>
-              <a:t>What do we learn?</a:t>
+              <a:rPr/>
+              <a:t>Students edit one settings cell</a:t>
             </a:r>
           </a:p>
         </p:txBody>
@@ -16710,55 +17234,29 @@
               </a:defRPr>
             </a:pPr>
             <a:r>
-              <a:t>•  No missing values are present.</a:t>
-            </a:r>
-          </a:p>
-          <a:p>
-            <a:pPr>
-              <a:spcAft>
-                <a:spcPts val="700"/>
-              </a:spcAft>
-              <a:defRPr sz="1700">
-                <a:solidFill>
-                  <a:srgbClr val="1A1F24"/>
-                </a:solidFill>
-                <a:latin typeface="Aptos"/>
-              </a:defRPr>
-            </a:pPr>
-            <a:r>
-              <a:t>•  Class 1 has 45 rows; class 0 has 14.</a:t>
-            </a:r>
-          </a:p>
-          <a:p>
-            <a:pPr>
-              <a:spcAft>
-                <a:spcPts val="700"/>
-              </a:spcAft>
-              <a:defRPr sz="1700">
-                <a:solidFill>
-                  <a:srgbClr val="1A1F24"/>
-                </a:solidFill>
-                <a:latin typeface="Aptos"/>
-              </a:defRPr>
-            </a:pPr>
-            <a:r>
-              <a:t>•  A majority-only rule is 76.3% accurate.</a:t>
-            </a:r>
-          </a:p>
-          <a:p>
-            <a:pPr>
-              <a:spcAft>
-                <a:spcPts val="700"/>
-              </a:spcAft>
-              <a:defRPr sz="1700">
-                <a:solidFill>
-                  <a:srgbClr val="1A1F24"/>
-                </a:solidFill>
-                <a:latin typeface="Aptos"/>
-              </a:defRPr>
-            </a:pPr>
-            <a:r>
-              <a:t>•  Accuracy alone may hide poor minority-class performance.</a:t>
+              <a:rPr/>
+              <a:t>•  TARGET_COLUMN: category to predict</a:t>
+            </a:r>
+          </a:p>
+          <a:p>
+            <a:pPr/>
+            <a:r>
+              <a:rPr/>
+              <a:t>•  ID_COLUMNS: fields to exclude</a:t>
+            </a:r>
+          </a:p>
+          <a:p>
+            <a:pPr/>
+            <a:r>
+              <a:rPr/>
+              <a:t>•  CATEGORICAL_COLUMNS: text or category codes</a:t>
+            </a:r>
+          </a:p>
+          <a:p>
+            <a:pPr/>
+            <a:r>
+              <a:rPr/>
+              <a:t>•  TEST_SIZE and MAX_DEPTH: optional settings</a:t>
             </a:r>
           </a:p>
         </p:txBody>
@@ -16837,7 +17335,154 @@
               </a:defRPr>
             </a:pPr>
             <a:r>
-              <a:t>Always compare the model with a baseline.</a:t>
+              <a:rPr/>
+              <a:t>This replaces the old Credit-only expected_columns check.</a:t>
+            </a:r>
+          </a:p>
+        </p:txBody>
+      </p:sp>
+      <p:sp>
+        <p:nvSpPr>
+          <p:cNvPr id="13" name="Rounded Rectangle 12"/>
+          <p:cNvSpPr/>
+          <p:nvPr/>
+        </p:nvSpPr>
+        <p:spPr>
+          <a:xfrm>
+            <a:off x="685800" y="1389888"/>
+            <a:ext cx="5897880" cy="2903572"/>
+          </a:xfrm>
+          <a:prstGeom prst="roundRect">
+            <a:avLst/>
+          </a:prstGeom>
+          <a:solidFill>
+            <a:srgbClr val="1A1F24"/>
+          </a:solidFill>
+          <a:ln>
+            <a:noFill/>
+          </a:ln>
+        </p:spPr>
+        <p:style>
+          <a:lnRef idx="1">
+            <a:schemeClr val="accent1"/>
+          </a:lnRef>
+          <a:fillRef idx="3">
+            <a:schemeClr val="accent1"/>
+          </a:fillRef>
+          <a:effectRef idx="2">
+            <a:schemeClr val="accent1"/>
+          </a:effectRef>
+          <a:fontRef idx="minor">
+            <a:schemeClr val="lt1"/>
+          </a:fontRef>
+        </p:style>
+        <p:txBody>
+          <a:bodyPr rtlCol="0" anchor="ctr"/>
+          <a:lstStyle/>
+          <a:p>
+            <a:pPr algn="ctr"/>
+          </a:p>
+        </p:txBody>
+      </p:sp>
+      <p:sp>
+        <p:nvSpPr>
+          <p:cNvPr id="14" name="TextBox 13"/>
+          <p:cNvSpPr txBox="1"/>
+          <p:nvPr/>
+        </p:nvSpPr>
+        <p:spPr>
+          <a:xfrm>
+            <a:off x="1039672" y="1680245"/>
+            <a:ext cx="5190134" cy="2322857"/>
+          </a:xfrm>
+          <a:prstGeom prst="rect">
+            <a:avLst/>
+          </a:prstGeom>
+          <a:noFill/>
+        </p:spPr>
+        <p:txBody>
+          <a:bodyPr wrap="square">
+            <a:spAutoFit/>
+          </a:bodyPr>
+          <a:lstStyle/>
+          <a:p>
+            <a:r>
+              <a:rPr sz="1500">
+                <a:solidFill>
+                  <a:srgbClr val="FFFFFF"/>
+                </a:solidFill>
+                <a:latin typeface="Aptos Mono"/>
+              </a:rPr>
+              <a:t>TARGET_COLUMN = "CREDIT"</a:t>
+            </a:r>
+          </a:p>
+          <a:p/>
+          <a:p>
+            <a:r>
+              <a:rPr sz="1500">
+                <a:solidFill>
+                  <a:srgbClr val="FFFFFF"/>
+                </a:solidFill>
+                <a:latin typeface="Aptos Mono"/>
+              </a:rPr>
+              <a:t>ID_COLUMNS = ["OBS#"]</a:t>
+            </a:r>
+          </a:p>
+          <a:p/>
+          <a:p>
+            <a:r>
+              <a:rPr sz="1500">
+                <a:solidFill>
+                  <a:srgbClr val="FFFFFF"/>
+                </a:solidFill>
+                <a:latin typeface="Aptos Mono"/>
+              </a:rPr>
+              <a:t>CATEGORICAL_COLUMNS = [</a:t>
+            </a:r>
+          </a:p>
+          <a:p>
+            <a:r>
+              <a:rPr sz="1500">
+                <a:solidFill>
+                  <a:srgbClr val="FFFFFF"/>
+                </a:solidFill>
+                <a:latin typeface="Aptos Mono"/>
+              </a:rPr>
+              <a:t>    "CHK_ACCT", "JOB", ...</a:t>
+            </a:r>
+          </a:p>
+          <a:p>
+            <a:r>
+              <a:rPr sz="1500">
+                <a:solidFill>
+                  <a:srgbClr val="FFFFFF"/>
+                </a:solidFill>
+                <a:latin typeface="Aptos Mono"/>
+              </a:rPr>
+              <a:t>]</a:t>
+            </a:r>
+          </a:p>
+          <a:p/>
+          <a:p>
+            <a:r>
+              <a:rPr sz="1500">
+                <a:solidFill>
+                  <a:srgbClr val="FFFFFF"/>
+                </a:solidFill>
+                <a:latin typeface="Aptos Mono"/>
+              </a:rPr>
+              <a:t>TEST_SIZE = 0.20</a:t>
+            </a:r>
+          </a:p>
+          <a:p>
+            <a:r>
+              <a:rPr sz="1500">
+                <a:solidFill>
+                  <a:srgbClr val="FFFFFF"/>
+                </a:solidFill>
+                <a:latin typeface="Aptos Mono"/>
+              </a:rPr>
+              <a:t>MAX_DEPTH = 3</a:t>
             </a:r>
           </a:p>
         </p:txBody>
@@ -16934,7 +17579,8 @@
               </a:defRPr>
             </a:pPr>
             <a:r>
-              <a:t>STEP 5 · PREPARE DATA</a:t>
+              <a:rPr/>
+              <a:t>STEP 5 · VALIDATE ROLES</a:t>
             </a:r>
           </a:p>
         </p:txBody>
@@ -16970,7 +17616,8 @@
               </a:defRPr>
             </a:pPr>
             <a:r>
-              <a:t>Select predictors and target</a:t>
+              <a:rPr/>
+              <a:t>Validate settings and select predictors</a:t>
             </a:r>
           </a:p>
         </p:txBody>
@@ -17207,35 +17854,97 @@
               </a:defRPr>
             </a:pPr>
             <a:r>
-              <a:t> 1  id_column = "OBS#"</a:t>
-            </a:r>
-            <a:br/>
-            <a:r>
-              <a:t> 2  target_column = "CREDIT"</a:t>
-            </a:r>
-            <a:br/>
-            <a:r>
-              <a:t> 3  feature_columns = [</a:t>
-            </a:r>
-            <a:br/>
-            <a:r>
-              <a:t> 4      c for c in df.columns</a:t>
-            </a:r>
-            <a:br/>
-            <a:r>
-              <a:t> 5      if c not in [id_column, target_column]</a:t>
-            </a:r>
-            <a:br/>
-            <a:r>
-              <a:t> 6  ]</a:t>
-            </a:r>
-            <a:br/>
-            <a:r>
-              <a:t> 7  X = df[feature_columns]</a:t>
-            </a:r>
-            <a:br/>
-            <a:r>
-              <a:t> 8  y = df[target_column]</a:t>
+              <a:rPr sz="1100">
+                <a:solidFill>
+                  <a:srgbClr val="FFFFFF"/>
+                </a:solidFill>
+                <a:latin typeface="Aptos Mono"/>
+              </a:rPr>
+              <a:t> 1  required = [TARGET_COLUMN] + ID_COLUMNS + CATEGORICAL_COLUMNS</a:t>
+            </a:r>
+          </a:p>
+          <a:p>
+            <a:pPr algn="l"/>
+            <a:r>
+              <a:rPr sz="1100">
+                <a:solidFill>
+                  <a:srgbClr val="FFFFFF"/>
+                </a:solidFill>
+                <a:latin typeface="Aptos Mono"/>
+              </a:rPr>
+              <a:t> 2  missing = [c for c in required if c not in df.columns]</a:t>
+            </a:r>
+          </a:p>
+          <a:p>
+            <a:pPr algn="l"/>
+            <a:r>
+              <a:rPr sz="1100">
+                <a:solidFill>
+                  <a:srgbClr val="FFFFFF"/>
+                </a:solidFill>
+                <a:latin typeface="Aptos Mono"/>
+              </a:rPr>
+              <a:t> 3  if missing: raise ValueError(...)</a:t>
+            </a:r>
+          </a:p>
+          <a:p>
+            <a:pPr algn="l"/>
+            <a:r>
+              <a:rPr sz="1100">
+                <a:solidFill>
+                  <a:srgbClr val="FFFFFF"/>
+                </a:solidFill>
+                <a:latin typeface="Aptos Mono"/>
+              </a:rPr>
+              <a:t> 4  feature_columns = [</a:t>
+            </a:r>
+          </a:p>
+          <a:p>
+            <a:pPr algn="l"/>
+            <a:r>
+              <a:rPr sz="1100">
+                <a:solidFill>
+                  <a:srgbClr val="FFFFFF"/>
+                </a:solidFill>
+                <a:latin typeface="Aptos Mono"/>
+              </a:rPr>
+              <a:t> 5      c for c in df.columns</a:t>
+            </a:r>
+          </a:p>
+          <a:p>
+            <a:pPr algn="l"/>
+            <a:r>
+              <a:rPr sz="1100">
+                <a:solidFill>
+                  <a:srgbClr val="FFFFFF"/>
+                </a:solidFill>
+                <a:latin typeface="Aptos Mono"/>
+              </a:rPr>
+              <a:t> 6      if c not in ID_COLUMNS + [TARGET_COLUMN]</a:t>
+            </a:r>
+          </a:p>
+          <a:p>
+            <a:pPr algn="l"/>
+            <a:r>
+              <a:rPr sz="1100">
+                <a:solidFill>
+                  <a:srgbClr val="FFFFFF"/>
+                </a:solidFill>
+                <a:latin typeface="Aptos Mono"/>
+              </a:rPr>
+              <a:t> 7  ]</a:t>
+            </a:r>
+          </a:p>
+          <a:p>
+            <a:pPr algn="l"/>
+            <a:r>
+              <a:rPr sz="1100">
+                <a:solidFill>
+                  <a:srgbClr val="FFFFFF"/>
+                </a:solidFill>
+                <a:latin typeface="Aptos Mono"/>
+              </a:rPr>
+              <a:t> 8  X, y = df[feature_columns], df[TARGET_COLUMN]</a:t>
             </a:r>
           </a:p>
         </p:txBody>
@@ -17271,27 +17980,50 @@
               </a:defRPr>
             </a:pPr>
             <a:r>
-              <a:t>1  Identifies the row ID, which is not a useful applicant characteristic.</a:t>
-            </a:r>
-            <a:br/>
-            <a:br/>
-            <a:r>
-              <a:t>2  Identifies the outcome to predict.</a:t>
-            </a:r>
-            <a:br/>
-            <a:br/>
-            <a:r>
-              <a:t>3–6  Keeps all remaining columns as predictors.</a:t>
-            </a:r>
-            <a:br/>
-            <a:br/>
-            <a:r>
-              <a:t>7  Creates the feature table X.</a:t>
-            </a:r>
-            <a:br/>
-            <a:br/>
-            <a:r>
-              <a:t>8  Creates the target vector y.</a:t>
+              <a:rPr/>
+              <a:t>1–3  Catch column-name mistakes early and show the available fields.</a:t>
+            </a:r>
+          </a:p>
+          <a:p>
+            <a:pPr algn="l"/>
+            <a:r>
+              <a:rPr/>
+              <a:t/>
+            </a:r>
+          </a:p>
+          <a:p>
+            <a:pPr algn="l"/>
+            <a:r>
+              <a:rPr/>
+              <a:t>4–7  Exclude the configured IDs and target.</a:t>
+            </a:r>
+          </a:p>
+          <a:p>
+            <a:pPr algn="l"/>
+            <a:r>
+              <a:rPr/>
+              <a:t/>
+            </a:r>
+          </a:p>
+          <a:p>
+            <a:pPr algn="l"/>
+            <a:r>
+              <a:rPr/>
+              <a:t>8  Create predictors X and target y.</a:t>
+            </a:r>
+          </a:p>
+          <a:p>
+            <a:pPr algn="l"/>
+            <a:r>
+              <a:rPr/>
+              <a:t/>
+            </a:r>
+          </a:p>
+          <a:p>
+            <a:pPr algn="l"/>
+            <a:r>
+              <a:rPr/>
+              <a:t>The same code works after students change the settings.</a:t>
             </a:r>
           </a:p>
         </p:txBody>

</xml_diff>